<commit_message>
Rename public grocery project to Summer Grocery Delivery in the Catskills
</commit_message>
<xml_diff>
--- a/resume/Anthony_Moncion_Portfolio.pptx
+++ b/resume/Anthony_Moncion_Portfolio.pptx
@@ -723,7 +723,7 @@
               <a:buNone/>
             </a:pPr>
             <a:r>
-              <a:t>Source: https://ruca-mobile-presentation-hub.vercel.app/portfolio/la-cosa-nostra/ and https://ruca-mobile-presentation-hub.vercel.app/portfolio/gourmet-glatt/. Both are independent projects. La Cosa Nostra is a local prototype. Gourmet Glatt is a design proposal with no implemented operation or client outcome claimed.</a:t>
+              <a:t>Source: https://ruca-mobile-presentation-hub.vercel.app/portfolio/la-cosa-nostra/ and https://ruca-mobile-presentation-hub.vercel.app/portfolio/catskills-grocery/. Both are independent projects. La Cosa Nostra is a local prototype. Summer Grocery Delivery in the Catskills is a design proposal with no implemented operation or client outcome claimed.</a:t>
             </a:r>
             <a:endParaRPr/>
           </a:p>
@@ -5700,7 +5700,7 @@
                 <a:ea typeface="Helvetica Neue"/>
                 <a:cs typeface="Helvetica Neue"/>
               </a:rPr>
-              <a:t>Gourmet Glatt Delivery Optimization</a:t>
+              <a:t>Summer Grocery Delivery in the Catskills</a:t>
             </a:r>
           </a:p>
           <a:p xmlns:a="http://schemas.openxmlformats.org/drawingml/2006/main">

</xml_diff>